<commit_message>
Proofread simpleqa-verified slides page by page with Gemini
</commit_message>
<xml_diff>
--- a/slides/datasets-in-10-minutes-simpleqa-verified.pptx
+++ b/slides/datasets-in-10-minutes-simpleqa-verified.pptx
@@ -9141,7 +9141,7 @@
                 <a:ea typeface="Noto Sans CJK JP"/>
                 <a:cs typeface="Noto Sans"/>
               </a:rPr>
-              <a:t>100問で、40正答・10誤答・50未回答なら</a:t>
+              <a:t>100問中、正答40・誤答10・未回答50なら</a:t>
             </a:r>
           </a:p>
         </p:txBody>
@@ -9884,7 +9884,7 @@
                 <a:ea typeface="Noto Sans CJK JP"/>
                 <a:cs typeface="Noto Sans"/>
               </a:rPr>
-              <a:t>全問での正答率と、答えた中での正答率を使う</a:t>
+              <a:t>全問での正答率と、回答した中での正答率を使う</a:t>
             </a:r>
           </a:p>
         </p:txBody>
@@ -10442,7 +10442,7 @@
                 <a:ea typeface="Noto Sans CJK JP"/>
                 <a:cs typeface="Noto Sans"/>
               </a:rPr>
-              <a:t>F1は、正答を広く出せることと、出した答えの正確さをまとめる。</a:t>
+              <a:t>F1は、正答を広く出せることと、出した答えの正確さを統合して評価する。</a:t>
             </a:r>
           </a:p>
         </p:txBody>
@@ -12627,7 +12627,7 @@
                 <a:ea typeface="Noto Sans CJK JP"/>
                 <a:cs typeface="Noto Sans"/>
               </a:rPr>
-              <a:t>公式モデルカード、2025年11月の比較。</a:t>
+              <a:t>公式モデルカードの比較（2025年11月、SimpleQA Verified）。</a:t>
             </a:r>
           </a:p>
           <a:p>
@@ -12865,7 +12865,7 @@
                 <a:ea typeface="Noto Sans CJK JP"/>
                 <a:cs typeface="Noto Sans"/>
               </a:rPr>
-              <a:t>論文のClaude Opus 4は、全問での正答率19.2%、答えた問題での正答率54.1%。回答を出した割合は35.5%である。</a:t>
+              <a:t>論文のClaude Opus 4は、全問での正答率が19.2%、答えた問題での正答率が54.1%で、回答率は35.5%である。</a:t>
             </a:r>
           </a:p>
           <a:p>
@@ -14335,7 +14335,7 @@
                 <a:ea typeface="Noto Sans CJK JP"/>
                 <a:cs typeface="Noto Sans"/>
               </a:rPr>
-              <a:t>元データには、コロンビアの自治体の創設日を問う質問が119件あった。同じ出典文書や似た型の問題が繰り返されることを減らす。</a:t>
+              <a:t>元データには、コロンビアの自治体の創設日を問う質問が119件あった。同じ出典文書や似た型の問題の重複を減らす。</a:t>
             </a:r>
           </a:p>
           <a:p>
@@ -16656,23 +16656,23 @@
                 <a:spcPct val="110000"/>
               </a:lnSpc>
               <a:buNone/>
-              <a:defRPr sz="2800" b="0">
-                <a:solidFill>
-                  <a:srgbClr val="303437"/>
-                </a:solidFill>
-                <a:latin typeface="Noto Sans"/>
-              </a:defRPr>
-            </a:pPr>
-            <a:r>
-              <a:rPr sz="2800" b="1" lang="ja-JP" altLang="en-US">
-                <a:solidFill>
-                  <a:srgbClr val="303437"/>
-                </a:solidFill>
-                <a:latin typeface="Noto Sans"/>
-                <a:ea typeface="Noto Sans CJK JP"/>
-                <a:cs typeface="Noto Sans"/>
-              </a:rPr>
-              <a:t>答えの種類は、日付・人物・数値・場所を含む</a:t>
+              <a:defRPr sz="2600" b="0">
+                <a:solidFill>
+                  <a:srgbClr val="303437"/>
+                </a:solidFill>
+                <a:latin typeface="Noto Sans"/>
+              </a:defRPr>
+            </a:pPr>
+            <a:r>
+              <a:rPr sz="2600" b="1" lang="ja-JP" altLang="en-US">
+                <a:solidFill>
+                  <a:srgbClr val="303437"/>
+                </a:solidFill>
+                <a:latin typeface="Noto Sans"/>
+                <a:ea typeface="Noto Sans CJK JP"/>
+                <a:cs typeface="Noto Sans"/>
+              </a:rPr>
+              <a:t>答えの種類には、日付・人物・数値・場所が含まれる</a:t>
             </a:r>
           </a:p>
         </p:txBody>
@@ -18514,7 +18514,7 @@
                 <a:ea typeface="Noto Sans CJK JP"/>
                 <a:cs typeface="Noto Sans"/>
               </a:rPr>
-              <a:t>SimpleQA Verifiedは、検索を使わず、モデルの内部知識から短い事実質問へ答える1,000問の評価である。</a:t>
+              <a:t>SimpleQA Verifiedは、検索を使わず、モデルの内部知識から短い事実質問に答える1,000問の評価である。</a:t>
             </a:r>
           </a:p>
           <a:p>
@@ -20445,7 +20445,7 @@
                 <a:ea typeface="Noto Sans CJK JP"/>
                 <a:cs typeface="Noto Sans"/>
               </a:rPr>
-              <a:t>1810年、François Aimé Louis Dumoulinが刊行した、Robinson Crusoeの旅を題材にした版画集は何枚か。</a:t>
+              <a:t>1810年、François Aimé Louis Dumoulinが刊行した、Robinson Crusoeの旅を題材にした版画集は何枚の版画からなるか。</a:t>
             </a:r>
           </a:p>
         </p:txBody>
@@ -24209,7 +24209,7 @@
                 <a:ea typeface="Noto Sans CJK JP"/>
                 <a:cs typeface="Noto Sans"/>
               </a:rPr>
-              <a:t>公開1,000問の話題別の構成</a:t>
+              <a:t>公開1,000問の話題別の構成（1/2）</a:t>
             </a:r>
           </a:p>
         </p:txBody>
@@ -25438,7 +25438,7 @@
                 <a:ea typeface="Noto Sans CJK JP"/>
                 <a:cs typeface="Noto Sans"/>
               </a:rPr>
-              <a:t>公開1,000問の話題別の構成</a:t>
+              <a:t>公開1,000問の話題別の構成（2/2）</a:t>
             </a:r>
           </a:p>
         </p:txBody>
@@ -26750,7 +26750,7 @@
                 <a:ea typeface="Noto Sans CJK JP"/>
                 <a:cs typeface="Noto Sans"/>
               </a:rPr>
-              <a:t>質問に直接答える部分へ注目し、付け加えられた背景説明を切り分ける。数値は参照正解に指定された範囲で判定する。</a:t>
+              <a:t>質問に直接答える部分に注目し、付け加えられた背景説明を切り分ける。数値は参照正解に指定された範囲で判定する。</a:t>
             </a:r>
           </a:p>
           <a:p>
@@ -26780,7 +26780,7 @@
                 <a:ea typeface="Noto Sans CJK JP"/>
                 <a:cs typeface="Noto Sans"/>
               </a:rPr>
-              <a:t>複数候補を挙げる場合は、最も有力な一つへ回答を定めていれば採点する。決めずに並べる回答や答えを出さない回答は、未回答とする。</a:t>
+              <a:t>複数候補を挙げる場合は、最も有力な一つに回答を定めていれば採点する。決めずに並べる回答や答えを出さない回答は、未回答とする。</a:t>
             </a:r>
           </a:p>
         </p:txBody>
@@ -27035,7 +27035,7 @@
                 <a:ea typeface="Noto Sans CJK JP"/>
                 <a:cs typeface="Noto Sans"/>
               </a:rPr>
-              <a:t>複数のモデルの回答を集め、元のSimpleQAの判定指示で各回答を10回ずつ採点する。温度を2.0にして、判定の一致しない回答を探した。</a:t>
+              <a:t>複数のモデルの回答を集め、元のSimpleQAの判定指示で各回答を10回ずつ採点した。温度を2.0にして、判定の一致しない回答を探した。</a:t>
             </a:r>
           </a:p>
           <a:p>
@@ -27760,26 +27760,26 @@
               <a:spcAft>
                 <a:spcPts val="800"/>
               </a:spcAft>
-              <a:buSzPct val="60455"/>
+              <a:buSzPct val="66500"/>
               <a:buFont typeface="Noto Sans CJK JP"/>
               <a:buChar char="●"/>
-              <a:defRPr sz="2200" b="0">
-                <a:solidFill>
-                  <a:srgbClr val="303437"/>
-                </a:solidFill>
-                <a:latin typeface="Noto Sans"/>
-              </a:defRPr>
-            </a:pPr>
-            <a:r>
-              <a:rPr sz="2200" b="0" lang="ja-JP" altLang="en-US">
-                <a:solidFill>
-                  <a:srgbClr val="303437"/>
-                </a:solidFill>
-                <a:latin typeface="Noto Sans"/>
-                <a:ea typeface="Noto Sans CJK JP"/>
-                <a:cs typeface="Noto Sans"/>
-              </a:rPr>
-              <a:t>第一著者はLukas Haas。Giovanni D’Antonio、Dipanjan DasとともにGoogle DeepMindに所属する。Gal YonaとSasha GoldshteinはGoogle Research。</a:t>
+              <a:defRPr sz="2000" b="0">
+                <a:solidFill>
+                  <a:srgbClr val="303437"/>
+                </a:solidFill>
+                <a:latin typeface="Noto Sans"/>
+              </a:defRPr>
+            </a:pPr>
+            <a:r>
+              <a:rPr sz="2000" b="0" lang="ja-JP" altLang="en-US">
+                <a:solidFill>
+                  <a:srgbClr val="303437"/>
+                </a:solidFill>
+                <a:latin typeface="Noto Sans"/>
+                <a:ea typeface="Noto Sans CJK JP"/>
+                <a:cs typeface="Noto Sans"/>
+              </a:rPr>
+              <a:t>第一著者はLukas Haas。Giovanni D’Antonio、Dipanjan DasとともにGoogle DeepMindに所属する。Gal YonaとSasha GoldshteinはGoogle Research所属。</a:t>
             </a:r>
           </a:p>
           <a:p>
@@ -27790,18 +27790,18 @@
               <a:spcAft>
                 <a:spcPts val="800"/>
               </a:spcAft>
-              <a:buSzPct val="60455"/>
+              <a:buSzPct val="66500"/>
               <a:buFont typeface="Noto Sans CJK JP"/>
               <a:buChar char="●"/>
-              <a:defRPr sz="2200" b="0">
-                <a:solidFill>
-                  <a:srgbClr val="303437"/>
-                </a:solidFill>
-                <a:latin typeface="Noto Sans"/>
-              </a:defRPr>
-            </a:pPr>
-            <a:r>
-              <a:rPr sz="2200" b="0" lang="ja-JP" altLang="en-US">
+              <a:defRPr sz="2000" b="0">
+                <a:solidFill>
+                  <a:srgbClr val="303437"/>
+                </a:solidFill>
+                <a:latin typeface="Noto Sans"/>
+              </a:defRPr>
+            </a:pPr>
+            <a:r>
+              <a:rPr sz="2000" b="0" lang="ja-JP" altLang="en-US">
                 <a:solidFill>
                   <a:srgbClr val="303437"/>
                 </a:solidFill>
@@ -27820,18 +27820,18 @@
               <a:spcAft>
                 <a:spcPts val="0"/>
               </a:spcAft>
-              <a:buSzPct val="60455"/>
+              <a:buSzPct val="66500"/>
               <a:buFont typeface="Noto Sans CJK JP"/>
               <a:buChar char="●"/>
-              <a:defRPr sz="2200" b="0">
-                <a:solidFill>
-                  <a:srgbClr val="303437"/>
-                </a:solidFill>
-                <a:latin typeface="Noto Sans"/>
-              </a:defRPr>
-            </a:pPr>
-            <a:r>
-              <a:rPr sz="2200" b="0" lang="ja-JP" altLang="en-US">
+              <a:defRPr sz="2000" b="0">
+                <a:solidFill>
+                  <a:srgbClr val="303437"/>
+                </a:solidFill>
+                <a:latin typeface="Noto Sans"/>
+              </a:defRPr>
+            </a:pPr>
+            <a:r>
+              <a:rPr sz="2000" b="0" lang="ja-JP" altLang="en-US">
                 <a:solidFill>
                   <a:srgbClr val="303437"/>
                 </a:solidFill>
@@ -29336,7 +29336,7 @@
                 <a:ea typeface="Noto Sans CJK JP"/>
                 <a:cs typeface="Noto Sans"/>
               </a:rPr>
-              <a:t>元のSimpleQAは、OpenAIが2024年に公開した事実質問の評価。難しい質問を人が作り、正答・誤答・未回答でモデルを採点する。</a:t>
+              <a:t>元のSimpleQAは、OpenAIが2024年に公開した事実質問の評価ベンチマーク。難しい質問を人が作り、正答・誤答・未回答でモデルを採点する。</a:t>
             </a:r>
           </a:p>
           <a:p>
@@ -29396,7 +29396,7 @@
                 <a:ea typeface="Noto Sans CJK JP"/>
                 <a:cs typeface="Noto Sans"/>
               </a:rPr>
-              <a:t>重複の整理から出典の再確認まで、著者自身が段階的に実施したと報告する。</a:t>
+              <a:t>重複の整理から出典の再確認まで、著者自身が段階的に実施したと報告している。</a:t>
             </a:r>
           </a:p>
         </p:txBody>

</xml_diff>

<commit_message>
Improve simpleqa-verified answer visibility and citation wording
</commit_message>
<xml_diff>
--- a/slides/datasets-in-10-minutes-simpleqa-verified.pptx
+++ b/slides/datasets-in-10-minutes-simpleqa-verified.pptx
@@ -8121,7 +8121,7 @@
             <a:r>
               <a:rPr sz="2200" b="1" lang="ja-JP" altLang="en-US">
                 <a:solidFill>
-                  <a:srgbClr val="303437"/>
+                  <a:schemeClr val="accent1"/>
                 </a:solidFill>
                 <a:latin typeface="Noto Sans"/>
                 <a:ea typeface="Noto Sans CJK JP"/>
@@ -19508,7 +19508,7 @@
             <a:r>
               <a:rPr sz="2200" b="1" lang="ja-JP" altLang="en-US">
                 <a:solidFill>
-                  <a:srgbClr val="303437"/>
+                  <a:schemeClr val="accent1"/>
                 </a:solidFill>
                 <a:latin typeface="Noto Sans"/>
                 <a:ea typeface="Noto Sans CJK JP"/>
@@ -19983,7 +19983,7 @@
             <a:r>
               <a:rPr sz="2200" b="1" lang="ja-JP" altLang="en-US">
                 <a:solidFill>
-                  <a:srgbClr val="303437"/>
+                  <a:schemeClr val="accent1"/>
                 </a:solidFill>
                 <a:latin typeface="Noto Sans"/>
                 <a:ea typeface="Noto Sans CJK JP"/>
@@ -20458,7 +20458,7 @@
             <a:r>
               <a:rPr sz="2200" b="1" lang="ja-JP" altLang="en-US">
                 <a:solidFill>
-                  <a:srgbClr val="303437"/>
+                  <a:schemeClr val="accent1"/>
                 </a:solidFill>
                 <a:latin typeface="Noto Sans"/>
                 <a:ea typeface="Noto Sans CJK JP"/>
@@ -20933,7 +20933,7 @@
             <a:r>
               <a:rPr sz="2200" b="1" lang="ja-JP" altLang="en-US">
                 <a:solidFill>
-                  <a:srgbClr val="303437"/>
+                  <a:schemeClr val="accent1"/>
                 </a:solidFill>
                 <a:latin typeface="Noto Sans"/>
                 <a:ea typeface="Noto Sans CJK JP"/>
@@ -21408,7 +21408,7 @@
             <a:r>
               <a:rPr sz="2200" b="1" lang="ja-JP" altLang="en-US">
                 <a:solidFill>
-                  <a:srgbClr val="303437"/>
+                  <a:schemeClr val="accent1"/>
                 </a:solidFill>
                 <a:latin typeface="Noto Sans"/>
                 <a:ea typeface="Noto Sans CJK JP"/>
@@ -21883,7 +21883,7 @@
             <a:r>
               <a:rPr sz="2200" b="1" lang="ja-JP" altLang="en-US">
                 <a:solidFill>
-                  <a:srgbClr val="303437"/>
+                  <a:schemeClr val="accent1"/>
                 </a:solidFill>
                 <a:latin typeface="Noto Sans"/>
                 <a:ea typeface="Noto Sans CJK JP"/>
@@ -22472,7 +22472,7 @@
             <a:r>
               <a:rPr sz="2200" b="1" lang="ja-JP" altLang="en-US">
                 <a:solidFill>
-                  <a:srgbClr val="303437"/>
+                  <a:schemeClr val="accent1"/>
                 </a:solidFill>
                 <a:latin typeface="Noto Sans"/>
                 <a:ea typeface="Noto Sans CJK JP"/>
@@ -22947,7 +22947,7 @@
             <a:r>
               <a:rPr sz="2200" b="1" lang="ja-JP" altLang="en-US">
                 <a:solidFill>
-                  <a:srgbClr val="303437"/>
+                  <a:schemeClr val="accent1"/>
                 </a:solidFill>
                 <a:latin typeface="Noto Sans"/>
                 <a:ea typeface="Noto Sans CJK JP"/>
@@ -23422,7 +23422,7 @@
             <a:r>
               <a:rPr sz="2200" b="1" lang="ja-JP" altLang="en-US">
                 <a:solidFill>
-                  <a:srgbClr val="303437"/>
+                  <a:schemeClr val="accent1"/>
                 </a:solidFill>
                 <a:latin typeface="Noto Sans"/>
                 <a:ea typeface="Noto Sans CJK JP"/>
@@ -23897,7 +23897,7 @@
             <a:r>
               <a:rPr sz="2200" b="1" lang="ja-JP" altLang="en-US">
                 <a:solidFill>
-                  <a:srgbClr val="303437"/>
+                  <a:schemeClr val="accent1"/>
                 </a:solidFill>
                 <a:latin typeface="Noto Sans"/>
                 <a:ea typeface="Noto Sans CJK JP"/>
@@ -30190,7 +30190,7 @@
             <a:r>
               <a:rPr sz="2200" b="1" lang="ja-JP" altLang="en-US">
                 <a:solidFill>
-                  <a:srgbClr val="303437"/>
+                  <a:schemeClr val="accent1"/>
                 </a:solidFill>
                 <a:latin typeface="Noto Sans"/>
                 <a:ea typeface="Noto Sans CJK JP"/>
@@ -30665,7 +30665,7 @@
             <a:r>
               <a:rPr sz="2200" b="1" lang="ja-JP" altLang="en-US">
                 <a:solidFill>
-                  <a:srgbClr val="303437"/>
+                  <a:schemeClr val="accent1"/>
                 </a:solidFill>
                 <a:latin typeface="Noto Sans"/>
                 <a:ea typeface="Noto Sans CJK JP"/>

</xml_diff>